<commit_message>
docs(a4): set three-slide Kyubin final handoff
Use Q1, Q2 and Challenges as the three main slides. Replace numbered slide 3 with the challenges slide, preserve the earlier technical slides under explicit backup filenames, and document the handoff order in the presentation README.

Generated-by: Codex
</commit_message>
<xml_diff>
--- a/presentation/final-draft-slide-3.pptx
+++ b/presentation/final-draft-slide-3.pptx
@@ -2,29 +2,29 @@
 <file path=ppt/presentation.xml><?xml version="1.0" encoding="utf-8"?>
 <p:presentation xmlns:p="http://schemas.openxmlformats.org/presentationml/2006/main" embedTrueTypeFonts="1" saveSubsetFonts="0">
   <p:sldMasterIdLst>
-    <p:sldMasterId xmlns:r="http://schemas.openxmlformats.org/officeDocument/2006/relationships" id="2147483648" r:id="Rc22f1b1f69ef4d04"/>
-    <p:sldMasterId xmlns:r="http://schemas.openxmlformats.org/officeDocument/2006/relationships" id="2147483650" r:id="R39eb23cd59804ffd"/>
+    <p:sldMasterId xmlns:r="http://schemas.openxmlformats.org/officeDocument/2006/relationships" id="2147483648" r:id="R111be91e95b84c79"/>
+    <p:sldMasterId xmlns:r="http://schemas.openxmlformats.org/officeDocument/2006/relationships" id="2147483650" r:id="R242b9d041b984376"/>
   </p:sldMasterIdLst>
   <p:notesMasterIdLst>
-    <p:notesMasterId xmlns:r="http://schemas.openxmlformats.org/officeDocument/2006/relationships" r:id="Rf05da2e7f0e94255"/>
+    <p:notesMasterId xmlns:r="http://schemas.openxmlformats.org/officeDocument/2006/relationships" r:id="R340c8313b2d64d02"/>
   </p:notesMasterIdLst>
   <p:sldIdLst>
-    <p:sldId xmlns:r="http://schemas.openxmlformats.org/officeDocument/2006/relationships" id="256" r:id="Re1060653792a4619"/>
+    <p:sldId xmlns:r="http://schemas.openxmlformats.org/officeDocument/2006/relationships" id="256" r:id="R7131e6d1ac4c4220"/>
   </p:sldIdLst>
   <p:sldSz cx="12192000" cy="6858000"/>
   <p:notesSz cx="6858000" cy="9144000"/>
   <p:embeddedFontLst>
     <p:embeddedFont>
       <p:font typeface="Manrope"/>
-      <p:regular xmlns:r="http://schemas.openxmlformats.org/officeDocument/2006/relationships" r:id="R0c0448522f814aed"/>
-      <p:bold xmlns:r="http://schemas.openxmlformats.org/officeDocument/2006/relationships" r:id="R6d24ee4fb58f45ae"/>
+      <p:regular xmlns:r="http://schemas.openxmlformats.org/officeDocument/2006/relationships" r:id="Red0c309578984cf8"/>
+      <p:bold xmlns:r="http://schemas.openxmlformats.org/officeDocument/2006/relationships" r:id="R7985d421663943c9"/>
     </p:embeddedFont>
     <p:embeddedFont>
       <p:font typeface="Roboto Mono"/>
-      <p:regular xmlns:r="http://schemas.openxmlformats.org/officeDocument/2006/relationships" r:id="Rf780fbdbd2184588"/>
-      <p:bold xmlns:r="http://schemas.openxmlformats.org/officeDocument/2006/relationships" r:id="R25777fd01a724908"/>
-      <p:italic xmlns:r="http://schemas.openxmlformats.org/officeDocument/2006/relationships" r:id="Rc69280ec67ff43d0"/>
-      <p:boldItalic xmlns:r="http://schemas.openxmlformats.org/officeDocument/2006/relationships" r:id="Rf915c2489339446a"/>
+      <p:regular xmlns:r="http://schemas.openxmlformats.org/officeDocument/2006/relationships" r:id="R1743c18c8b854401"/>
+      <p:bold xmlns:r="http://schemas.openxmlformats.org/officeDocument/2006/relationships" r:id="R39e5f509c9144859"/>
+      <p:italic xmlns:r="http://schemas.openxmlformats.org/officeDocument/2006/relationships" r:id="R50bd5d81b23f4dc9"/>
+      <p:boldItalic xmlns:r="http://schemas.openxmlformats.org/officeDocument/2006/relationships" r:id="R8ba9596a555a4406"/>
     </p:embeddedFont>
   </p:embeddedFontLst>
   <p:defaultTextStyle>
@@ -719,7 +719,7 @@
               <a:buNone/>
             </a:pPr>
             <a:r>
-              <a:t>Presenter: Kyubin Park. Suggested speaking slot: 30–35 seconds.</a:t>
+              <a:t>Final Kyubin handoff: slide 3 of 3, after Q1 project choice and Q2 issue choice. The two earlier TIKA-4431 technical slides are separate backups.</a:t>
             </a:r>
             <a:endParaRPr/>
           </a:p>
@@ -749,7 +749,22 @@
               <a:buNone/>
             </a:pPr>
             <a:r>
-              <a:t>My issue concerned CSV filenames containing a hash. Tika detected the same CSV bytes as plain text for a name such as Lorem-Ipsum hash one-two-three dot CSV. Its URI parser interpreted everything after the hash as a fragment, as it would in a web address. That left Lorem-Ipsum as the path, without the CSV extension. Preserving the full filename hint restores the expected CSV result.</a:t>
+              <a:t>Author and presenter: Kyubin Park.</a:t>
+            </a:r>
+            <a:endParaRPr/>
+          </a:p>
+          <a:p xmlns:a="http://schemas.openxmlformats.org/drawingml/2006/main">
+            <a:pPr marL="0" lvl="0" indent="0" algn="l">
+              <a:spcBef>
+                <a:spcPts val="0"/>
+              </a:spcBef>
+              <a:spcAft>
+                <a:spcPts val="0"/>
+              </a:spcAft>
+              <a:buNone/>
+            </a:pPr>
+            <a:r>
+              <a:t>AI assistance: Codex helped clarify URL fragment semantics, draft the slide and suggested script, and adapt the group template.</a:t>
             </a:r>
             <a:endParaRPr/>
           </a:p>
@@ -779,7 +794,22 @@
               <a:buNone/>
             </a:pPr>
             <a:r>
-              <a:t>Sources: https://github.com/u8026876/comp2120-gyg-a5/pull/7 and https://github.com/u8026876/comp2120-gyg-a5/issues/1 . Published commit: 86483a61d15e22a03f1bbdf6e0c199012baa34ed. Local evidence recorded 21 October 2026; PR status checked 25 October 2026. The group PR is open and unmerged. Apache submission is a separate follow-up.</a:t>
+              <a:t>Suggested speaking script, approximately 55 seconds:</a:t>
+            </a:r>
+            <a:endParaRPr/>
+          </a:p>
+          <a:p xmlns:a="http://schemas.openxmlformats.org/drawingml/2006/main">
+            <a:pPr marL="0" lvl="0" indent="0" algn="l">
+              <a:spcBef>
+                <a:spcPts val="0"/>
+              </a:spcBef>
+              <a:spcAft>
+                <a:spcPts val="0"/>
+              </a:spcAft>
+              <a:buNone/>
+            </a:pPr>
+            <a:r>
+              <a:t>One challenge was deciding what correct behavior should mean when the input is ambiguous. Take filename.txt hash file2.csv. As a filesystem name, the hash belongs to the name and the final extension is CSV. As a URL reference, the path ends at filename.txt and file2.csv is a fragment. That fragment does not automatically identify another CSV file. TIKA-4431 exposed this boundary: adding a hash to a CSV filename changed detection to plain text, even though the content stayed the same. Simply keeping or removing every hash would mishandle one of these interpretations. We needed a policy for filename-like inputs and explicit URLs, then regression tests that protect both. The lesson was that tests can preserve a decision, but first we have to decide what behavior we intend.</a:t>
             </a:r>
             <a:endParaRPr/>
           </a:p>
@@ -809,7 +839,52 @@
               <a:buNone/>
             </a:pPr>
             <a:r>
-              <a:t>Exact implementation boundary: no URI scheme or raw authority; compare the last raw hash and dot before the first query delimiter, before percent decoding, then escape hashes for path extraction. Bare inputs can also be relative URIs, so this is a filename heuristic, not proof of caller intent or content. Explicit schemes and network authorities retain URI handling.</a:t>
+              <a:t>Technical scope:</a:t>
+            </a:r>
+            <a:endParaRPr/>
+          </a:p>
+          <a:p xmlns:a="http://schemas.openxmlformats.org/drawingml/2006/main">
+            <a:pPr marL="0" lvl="0" indent="0" algn="l">
+              <a:spcBef>
+                <a:spcPts val="0"/>
+              </a:spcBef>
+              <a:spcAft>
+                <a:spcPts val="0"/>
+              </a:spcAft>
+              <a:buNone/>
+            </a:pPr>
+            <a:r>
+              <a:t>The illustrated name is an explanatory example. The reported reproducer is Lorem-Ipsum#123.csv. The slide compares filename extension hints, not a guarantee of file content or server Content-Type.</a:t>
+            </a:r>
+            <a:endParaRPr/>
+          </a:p>
+          <a:p xmlns:a="http://schemas.openxmlformats.org/drawingml/2006/main">
+            <a:pPr marL="0" lvl="0" indent="0" algn="l">
+              <a:spcBef>
+                <a:spcPts val="0"/>
+              </a:spcBef>
+              <a:spcAft>
+                <a:spcPts val="0"/>
+              </a:spcAft>
+              <a:buNone/>
+            </a:pPr>
+            <a:r>
+              <a:t>A bare filename-like string can also be a relative URL reference. An explicit example is https://example.test/filename.txt#file2.csv. The fragment semantics depend on the representation, and may be undefined for that particular text resource.</a:t>
+            </a:r>
+            <a:endParaRPr/>
+          </a:p>
+          <a:p xmlns:a="http://schemas.openxmlformats.org/drawingml/2006/main">
+            <a:pPr marL="0" lvl="0" indent="0" algn="l">
+              <a:spcBef>
+                <a:spcPts val="0"/>
+              </a:spcBef>
+              <a:spcAft>
+                <a:spcPts val="0"/>
+              </a:spcAft>
+              <a:buNone/>
+            </a:pPr>
+            <a:r>
+              <a:t>The inspected local patch treats a hash before the last raw dot before a question mark as literal when the parsed input has neither a scheme nor an authority. Explicit URLs retain URI fragment semantics. This is the policy represented by the local patch, not a universal way to infer caller intent.</a:t>
             </a:r>
             <a:endParaRPr/>
           </a:p>
@@ -839,7 +914,7 @@
               <a:buNone/>
             </a:pPr>
             <a:r>
-              <a:t>Validation on the group-base patch: with new tests retained and only the production fix absent, 33 TikaDetectionTest cases reported 9 failures and 0 errors. With the fix restored, all 33 passed. The saved core unit run reported 1,391 tests, 0 failures, 0 errors and 11 skipped. Core/reactor prerequisites and style/license checks passed. This does not establish full-repository validation or remote CI. No fresh code test run was performed for this presentation.</a:t>
+              <a:t>Sources:</a:t>
             </a:r>
             <a:endParaRPr/>
           </a:p>
@@ -854,7 +929,7 @@
               <a:buNone/>
             </a:pPr>
             <a:r>
-              <a:t/>
+              <a:t>https://issues.apache.org/jira/browse/TIKA-4431</a:t>
             </a:r>
             <a:endParaRPr/>
           </a:p>
@@ -869,7 +944,7 @@
               <a:buNone/>
             </a:pPr>
             <a:r>
-              <a:t>Command: ./mvnw.cmd clean install -pl tika-core -am -Ppedantic -Dtika.test.locale=random</a:t>
+              <a:t>https://www.rfc-editor.org/rfc/rfc3986#section-3.5</a:t>
             </a:r>
             <a:endParaRPr/>
           </a:p>
@@ -884,7 +959,7 @@
               <a:buNone/>
             </a:pPr>
             <a:r>
-              <a:t/>
+              <a:t>https://www.rfc-editor.org/rfc/rfc3986#section-4.2</a:t>
             </a:r>
             <a:endParaRPr/>
           </a:p>
@@ -899,7 +974,37 @@
               <a:buNone/>
             </a:pPr>
             <a:r>
-              <a:t>Attribution: Kyubin Park (@u8026876) owns TIKA-4431. Codex assisted investigation, implementation, tests and presentation drafting. Jiajun (@Lynnbb88) and Terry (@zjt060523terry) supplied scoped peer reviews with their own assistance disclosures. The visual template is the group kit; Jiajun's presentation is a layout reference, not the source of this contribution.</a:t>
+              <a:t>Implementation reference: tika-core/src/main/java/org/apache/tika/mime/MimeTypes.java, local TIKA-4431 patch, lines 577-590.</a:t>
+            </a:r>
+            <a:endParaRPr/>
+          </a:p>
+          <a:p xmlns:a="http://schemas.openxmlformats.org/drawingml/2006/main">
+            <a:pPr marL="0" lvl="0" indent="0" algn="l">
+              <a:spcBef>
+                <a:spcPts val="0"/>
+              </a:spcBef>
+              <a:spcAft>
+                <a:spcPts val="0"/>
+              </a:spcAft>
+              <a:buNone/>
+            </a:pPr>
+            <a:r>
+              <a:t>Regression reference: tika-core/src/test/java/org/apache/tika/TikaDetectionTest.java, local TIKA-4431 patch, lines 54-77.</a:t>
+            </a:r>
+            <a:endParaRPr/>
+          </a:p>
+          <a:p xmlns:a="http://schemas.openxmlformats.org/drawingml/2006/main">
+            <a:pPr marL="0" lvl="0" indent="0" algn="l">
+              <a:spcBef>
+                <a:spcPts val="0"/>
+              </a:spcBef>
+              <a:spcAft>
+                <a:spcPts val="0"/>
+              </a:spcAft>
+              <a:buNone/>
+            </a:pPr>
+            <a:r>
+              <a:t>No new build or test run is asserted by this slide. No claim of upstream acceptance or merge is made.</a:t>
             </a:r>
             <a:endParaRPr/>
           </a:p>
@@ -947,7 +1052,7 @@
           <p:cNvPr id="11" name="Google Shape;11;p2">
             <a:extLst xmlns:a="http://schemas.openxmlformats.org/drawingml/2006/main">
               <a:ext uri="{FF2B5EF4-FFF2-40B4-BE49-F238E27FC236}">
-                <a16:creationId xmlns:a16="http://schemas.microsoft.com/office/drawing/2014/main" id="{0D8847DF-A93B-4F3D-89D3-2355E6069E98}"/>
+                <a16:creationId xmlns:a16="http://schemas.microsoft.com/office/drawing/2014/main" id="{1C100767-00C6-444B-970A-8E277D00A063}"/>
               </a:ext>
             </a:extLst>
           </p:cNvPr>
@@ -1084,7 +1189,7 @@
           <p:cNvPr id="12" name="Google Shape;12;p2">
             <a:extLst xmlns:a="http://schemas.openxmlformats.org/drawingml/2006/main">
               <a:ext uri="{FF2B5EF4-FFF2-40B4-BE49-F238E27FC236}">
-                <a16:creationId xmlns:a16="http://schemas.microsoft.com/office/drawing/2014/main" id="{1938093B-CCC4-41B6-8A9F-8E5B408792A7}"/>
+                <a16:creationId xmlns:a16="http://schemas.microsoft.com/office/drawing/2014/main" id="{233BC48A-E610-4DCE-B6DB-9C80D2C6FE27}"/>
               </a:ext>
             </a:extLst>
           </p:cNvPr>
@@ -1238,7 +1343,7 @@
           <p:cNvPr id="15" name="Google Shape;15;p4">
             <a:extLst xmlns:a="http://schemas.openxmlformats.org/drawingml/2006/main">
               <a:ext uri="{FF2B5EF4-FFF2-40B4-BE49-F238E27FC236}">
-                <a16:creationId xmlns:a16="http://schemas.microsoft.com/office/drawing/2014/main" id="{4E354046-221B-4934-A60F-8FBE2D8289F4}"/>
+                <a16:creationId xmlns:a16="http://schemas.microsoft.com/office/drawing/2014/main" id="{CED5DE22-EA14-45E7-99D5-92AFE56D873B}"/>
               </a:ext>
             </a:extLst>
           </p:cNvPr>
@@ -1375,7 +1480,7 @@
           <p:cNvPr id="16" name="Google Shape;16;p4">
             <a:extLst xmlns:a="http://schemas.openxmlformats.org/drawingml/2006/main">
               <a:ext uri="{FF2B5EF4-FFF2-40B4-BE49-F238E27FC236}">
-                <a16:creationId xmlns:a16="http://schemas.microsoft.com/office/drawing/2014/main" id="{7CAD29F7-942E-474C-9AD4-FDEC3F0D82AA}"/>
+                <a16:creationId xmlns:a16="http://schemas.microsoft.com/office/drawing/2014/main" id="{5608EF53-DD0A-4501-91D4-604A742D54DF}"/>
               </a:ext>
             </a:extLst>
           </p:cNvPr>
@@ -1512,7 +1617,7 @@
           <p:cNvPr id="17" name="Google Shape;17;p4">
             <a:extLst xmlns:a="http://schemas.openxmlformats.org/drawingml/2006/main">
               <a:ext uri="{FF2B5EF4-FFF2-40B4-BE49-F238E27FC236}">
-                <a16:creationId xmlns:a16="http://schemas.microsoft.com/office/drawing/2014/main" id="{AE79A4DE-6D3A-4CDD-A5AB-37AD23D1E5DF}"/>
+                <a16:creationId xmlns:a16="http://schemas.microsoft.com/office/drawing/2014/main" id="{A172251A-9938-4EB6-9D5E-9F8A88CD7E09}"/>
               </a:ext>
             </a:extLst>
           </p:cNvPr>
@@ -1666,7 +1771,7 @@
           <p:cNvPr id="19" name="Google Shape;19;p5">
             <a:extLst xmlns:a="http://schemas.openxmlformats.org/drawingml/2006/main">
               <a:ext uri="{FF2B5EF4-FFF2-40B4-BE49-F238E27FC236}">
-                <a16:creationId xmlns:a16="http://schemas.microsoft.com/office/drawing/2014/main" id="{DE011E28-65D2-4C5B-B272-0AC1EC23C6BF}"/>
+                <a16:creationId xmlns:a16="http://schemas.microsoft.com/office/drawing/2014/main" id="{5B151365-FF02-4958-9BF9-74E9946BA58C}"/>
               </a:ext>
             </a:extLst>
           </p:cNvPr>
@@ -1803,7 +1908,7 @@
           <p:cNvPr id="20" name="Google Shape;20;p5">
             <a:extLst xmlns:a="http://schemas.openxmlformats.org/drawingml/2006/main">
               <a:ext uri="{FF2B5EF4-FFF2-40B4-BE49-F238E27FC236}">
-                <a16:creationId xmlns:a16="http://schemas.microsoft.com/office/drawing/2014/main" id="{C56012C0-0208-4FE9-BE53-CA2E974615B4}"/>
+                <a16:creationId xmlns:a16="http://schemas.microsoft.com/office/drawing/2014/main" id="{611B93BC-950A-4ACF-833E-C02B77ED06F4}"/>
               </a:ext>
             </a:extLst>
           </p:cNvPr>
@@ -1940,7 +2045,7 @@
           <p:cNvPr id="21" name="Google Shape;21;p5">
             <a:extLst xmlns:a="http://schemas.openxmlformats.org/drawingml/2006/main">
               <a:ext uri="{FF2B5EF4-FFF2-40B4-BE49-F238E27FC236}">
-                <a16:creationId xmlns:a16="http://schemas.microsoft.com/office/drawing/2014/main" id="{131646E8-7D90-481C-B5AF-DED2C11CAC1E}"/>
+                <a16:creationId xmlns:a16="http://schemas.microsoft.com/office/drawing/2014/main" id="{2394E3D4-6B65-4954-854A-7CB3C0729EED}"/>
               </a:ext>
             </a:extLst>
           </p:cNvPr>
@@ -2094,7 +2199,7 @@
           <p:cNvPr id="23" name="Google Shape;23;p6">
             <a:extLst xmlns:a="http://schemas.openxmlformats.org/drawingml/2006/main">
               <a:ext uri="{FF2B5EF4-FFF2-40B4-BE49-F238E27FC236}">
-                <a16:creationId xmlns:a16="http://schemas.microsoft.com/office/drawing/2014/main" id="{0A9EA113-753D-4D4A-BCEA-1C8A9AD2E5F5}"/>
+                <a16:creationId xmlns:a16="http://schemas.microsoft.com/office/drawing/2014/main" id="{B78F864E-AFC8-4EFC-8409-B2D60924BA1A}"/>
               </a:ext>
             </a:extLst>
           </p:cNvPr>
@@ -2231,7 +2336,7 @@
           <p:cNvPr id="24" name="Google Shape;24;p6">
             <a:extLst xmlns:a="http://schemas.openxmlformats.org/drawingml/2006/main">
               <a:ext uri="{FF2B5EF4-FFF2-40B4-BE49-F238E27FC236}">
-                <a16:creationId xmlns:a16="http://schemas.microsoft.com/office/drawing/2014/main" id="{6558D1AF-11A0-43DA-A71F-67BB9806CA83}"/>
+                <a16:creationId xmlns:a16="http://schemas.microsoft.com/office/drawing/2014/main" id="{F51EBEE0-DF59-4EF5-A9CA-4122C6C1E62D}"/>
               </a:ext>
             </a:extLst>
           </p:cNvPr>
@@ -2385,7 +2490,7 @@
           <p:cNvPr id="26" name="Google Shape;26;p7">
             <a:extLst xmlns:a="http://schemas.openxmlformats.org/drawingml/2006/main">
               <a:ext uri="{FF2B5EF4-FFF2-40B4-BE49-F238E27FC236}">
-                <a16:creationId xmlns:a16="http://schemas.microsoft.com/office/drawing/2014/main" id="{E9D7A9EF-9B89-4087-991A-5E1764970182}"/>
+                <a16:creationId xmlns:a16="http://schemas.microsoft.com/office/drawing/2014/main" id="{81EEA9D0-67EF-4645-B8B1-95B99D8DC989}"/>
               </a:ext>
             </a:extLst>
           </p:cNvPr>
@@ -2522,7 +2627,7 @@
           <p:cNvPr id="27" name="Google Shape;27;p7">
             <a:extLst xmlns:a="http://schemas.openxmlformats.org/drawingml/2006/main">
               <a:ext uri="{FF2B5EF4-FFF2-40B4-BE49-F238E27FC236}">
-                <a16:creationId xmlns:a16="http://schemas.microsoft.com/office/drawing/2014/main" id="{77DFC64A-7DB5-479B-B0A5-00B8B99A1931}"/>
+                <a16:creationId xmlns:a16="http://schemas.microsoft.com/office/drawing/2014/main" id="{E255E37C-2C47-47C7-8FFF-033A4D99CCA8}"/>
               </a:ext>
             </a:extLst>
           </p:cNvPr>
@@ -2682,7 +2787,7 @@
   </p:cSld>
   <p:clrMap bg1="lt1" tx1="dk1" bg2="dk2" tx2="lt2" accent1="accent1" accent2="accent2" accent3="accent3" accent4="accent4" accent5="accent5" accent6="accent6" hlink="hlink" folHlink="folHlink"/>
   <p:sldLayoutIdLst>
-    <p:sldLayoutId xmlns:r="http://schemas.openxmlformats.org/officeDocument/2006/relationships" id="2147483649" r:id="R302de68c3da94fec"/>
+    <p:sldLayoutId xmlns:r="http://schemas.openxmlformats.org/officeDocument/2006/relationships" id="2147483649" r:id="Rdd07a395e72d4bf6"/>
   </p:sldLayoutIdLst>
   <p:hf sldNum="0" hdr="0" ftr="0" dt="0"/>
   <p:txStyles>
@@ -3367,10 +3472,10 @@
   </p:cSld>
   <p:clrMap bg1="lt1" tx1="dk1" bg2="dk2" tx2="lt2" accent1="accent1" accent2="accent2" accent3="accent3" accent4="accent4" accent5="accent5" accent6="accent6" hlink="hlink" folHlink="folHlink"/>
   <p:sldLayoutIdLst>
-    <p:sldLayoutId xmlns:r="http://schemas.openxmlformats.org/officeDocument/2006/relationships" id="2147483651" r:id="R79f7fd7416464977"/>
-    <p:sldLayoutId xmlns:r="http://schemas.openxmlformats.org/officeDocument/2006/relationships" id="2147483652" r:id="R287680b59fee4a87"/>
-    <p:sldLayoutId xmlns:r="http://schemas.openxmlformats.org/officeDocument/2006/relationships" id="2147483653" r:id="R4a3e7a2095a9427f"/>
-    <p:sldLayoutId xmlns:r="http://schemas.openxmlformats.org/officeDocument/2006/relationships" id="2147483654" r:id="R01efe6d8a9a04d35"/>
+    <p:sldLayoutId xmlns:r="http://schemas.openxmlformats.org/officeDocument/2006/relationships" id="2147483651" r:id="Rb982045a63054d98"/>
+    <p:sldLayoutId xmlns:r="http://schemas.openxmlformats.org/officeDocument/2006/relationships" id="2147483652" r:id="R9620f5cd9af24f2f"/>
+    <p:sldLayoutId xmlns:r="http://schemas.openxmlformats.org/officeDocument/2006/relationships" id="2147483653" r:id="R58fa4eccce5b4e16"/>
+    <p:sldLayoutId xmlns:r="http://schemas.openxmlformats.org/officeDocument/2006/relationships" id="2147483654" r:id="Rba9ae69a2cad4d25"/>
   </p:sldLayoutIdLst>
   <p:hf sldNum="0" hdr="0" ftr="0" dt="0"/>
   <p:txStyles>
@@ -4592,7 +4697,7 @@
           <p:cNvPr id="42" name="Google Shape;42;p9">
             <a:extLst xmlns:a="http://schemas.openxmlformats.org/drawingml/2006/main">
               <a:ext uri="{FF2B5EF4-FFF2-40B4-BE49-F238E27FC236}">
-                <a16:creationId xmlns:a16="http://schemas.microsoft.com/office/drawing/2014/main" id="{13C05C6B-CA28-4EAC-A851-73EBABC996BC}"/>
+                <a16:creationId xmlns:a16="http://schemas.microsoft.com/office/drawing/2014/main" id="{00800A4B-158C-48C2-9DBB-2E36FB51E43C}"/>
               </a:ext>
             </a:extLst>
           </p:cNvPr>
@@ -4643,7 +4748,7 @@
           <p:cNvPr id="43" name="Google Shape;43;p9">
             <a:extLst xmlns:a="http://schemas.openxmlformats.org/drawingml/2006/main">
               <a:ext uri="{FF2B5EF4-FFF2-40B4-BE49-F238E27FC236}">
-                <a16:creationId xmlns:a16="http://schemas.microsoft.com/office/drawing/2014/main" id="{31A941C7-CFE2-4384-B01C-E977482EBC00}"/>
+                <a16:creationId xmlns:a16="http://schemas.microsoft.com/office/drawing/2014/main" id="{423D4A9B-5460-41B8-A391-4F29A36EF5EF}"/>
               </a:ext>
             </a:extLst>
           </p:cNvPr>
@@ -4689,71 +4794,7 @@
                 <a:ea typeface="Roboto Mono"/>
                 <a:cs typeface="Roboto Mono"/>
               </a:rPr>
-              <a:t>TIKA-4431 / FILENAME DETECTION</a:t>
-            </a:r>
-            <a:endParaRPr sz="1100">
-              <a:solidFill>
-                <a:srgbClr val="B8C7AB"/>
-              </a:solidFill>
-              <a:latin typeface="Roboto Mono"/>
-              <a:ea typeface="Roboto Mono"/>
-              <a:cs typeface="Roboto Mono"/>
-            </a:endParaRPr>
-          </a:p>
-        </p:txBody>
-      </p:sp>
-      <p:sp>
-        <p:nvSpPr>
-          <p:cNvPr id="44" name="Google Shape;44;p9">
-            <a:extLst xmlns:a="http://schemas.openxmlformats.org/drawingml/2006/main">
-              <a:ext uri="{FF2B5EF4-FFF2-40B4-BE49-F238E27FC236}">
-                <a16:creationId xmlns:a16="http://schemas.microsoft.com/office/drawing/2014/main" id="{B7EDA4E6-CB59-4E1E-8012-B39FC9B76A59}"/>
-              </a:ext>
-            </a:extLst>
-          </p:cNvPr>
-          <p:cNvSpPr>
-            <a:spLocks xmlns:a="http://schemas.openxmlformats.org/drawingml/2006/main" noGrp="1"/>
-          </p:cNvSpPr>
-          <p:nvPr/>
-        </p:nvSpPr>
-        <p:spPr>
-          <a:xfrm xmlns:a="http://schemas.openxmlformats.org/drawingml/2006/main">
-            <a:off x="10871200" y="330200"/>
-            <a:ext cx="711300" cy="279300"/>
-          </a:xfrm>
-          <a:prstGeom xmlns:a="http://schemas.openxmlformats.org/drawingml/2006/main" prst="rect">
-            <a:avLst/>
-          </a:prstGeom>
-          <a:noFill xmlns:a="http://schemas.openxmlformats.org/drawingml/2006/main"/>
-          <a:ln xmlns:a="http://schemas.openxmlformats.org/drawingml/2006/main">
-            <a:noFill/>
-          </a:ln>
-        </p:spPr>
-        <p:txBody>
-          <a:bodyPr xmlns:a="http://schemas.openxmlformats.org/drawingml/2006/main" spcFirstLastPara="1" wrap="square" lIns="0" tIns="0" rIns="0" bIns="0" anchor="t">
-            <a:noAutofit/>
-          </a:bodyPr>
-          <a:lstStyle xmlns:a="http://schemas.openxmlformats.org/drawingml/2006/main"/>
-          <a:p xmlns:a="http://schemas.openxmlformats.org/drawingml/2006/main">
-            <a:pPr marL="0" marR="0" lvl="0" indent="0" algn="r">
-              <a:spcBef>
-                <a:spcPts val="0"/>
-              </a:spcBef>
-              <a:spcAft>
-                <a:spcPts val="0"/>
-              </a:spcAft>
-              <a:buNone/>
-            </a:pPr>
-            <a:r>
-              <a:rPr sz="1100">
-                <a:solidFill>
-                  <a:srgbClr val="B8C7AB"/>
-                </a:solidFill>
-                <a:latin typeface="Roboto Mono"/>
-                <a:ea typeface="Roboto Mono"/>
-                <a:cs typeface="Roboto Mono"/>
-              </a:rPr>
-              <a:t>03</a:t>
+              <a:t>PROJECT CHALLENGES / TIKA-4431</a:t>
             </a:r>
             <a:endParaRPr sz="1100">
               <a:solidFill>
@@ -4771,7 +4812,7 @@
           <p:cNvPr id="45" name="Google Shape;45;p9">
             <a:extLst xmlns:a="http://schemas.openxmlformats.org/drawingml/2006/main">
               <a:ext uri="{FF2B5EF4-FFF2-40B4-BE49-F238E27FC236}">
-                <a16:creationId xmlns:a16="http://schemas.microsoft.com/office/drawing/2014/main" id="{D3BD6B5B-8A88-4DB5-A88A-3A532D9227AE}"/>
+                <a16:creationId xmlns:a16="http://schemas.microsoft.com/office/drawing/2014/main" id="{EFD97C2C-F810-4C31-BA73-E9CA2BA53C42}"/>
               </a:ext>
             </a:extLst>
           </p:cNvPr>
@@ -4819,7 +4860,7 @@
                 <a:ea typeface="Manrope"/>
                 <a:cs typeface="Manrope"/>
               </a:rPr>
-              <a:t>A filename lost its CSV extension</a:t>
+              <a:t>Defining correct behavior</a:t>
             </a:r>
             <a:endParaRPr sz="3500" b="1">
               <a:solidFill>
@@ -4837,7 +4878,7 @@
           <p:cNvPr id="46" name="Google Shape;46;p9">
             <a:extLst xmlns:a="http://schemas.openxmlformats.org/drawingml/2006/main">
               <a:ext uri="{FF2B5EF4-FFF2-40B4-BE49-F238E27FC236}">
-                <a16:creationId xmlns:a16="http://schemas.microsoft.com/office/drawing/2014/main" id="{5B893742-5E3A-4FB5-A039-4FC7C708EED8}"/>
+                <a16:creationId xmlns:a16="http://schemas.microsoft.com/office/drawing/2014/main" id="{759DC111-B1E6-4874-A349-437F901EDDB7}"/>
               </a:ext>
             </a:extLst>
           </p:cNvPr>
@@ -4883,7 +4924,7 @@
                 <a:ea typeface="Manrope"/>
                 <a:cs typeface="Manrope"/>
               </a:rPr>
-              <a:t>Kyubin Park / @u8026876</a:t>
+              <a:t>Kyubin Park</a:t>
             </a:r>
             <a:endParaRPr sz="900">
               <a:solidFill>
@@ -4901,7 +4942,7 @@
           <p:cNvPr id="47" name="Google Shape;47;p9">
             <a:extLst xmlns:a="http://schemas.openxmlformats.org/drawingml/2006/main">
               <a:ext uri="{FF2B5EF4-FFF2-40B4-BE49-F238E27FC236}">
-                <a16:creationId xmlns:a16="http://schemas.microsoft.com/office/drawing/2014/main" id="{4D574D7E-3D86-494A-B76C-A74EB7A85F5B}"/>
+                <a16:creationId xmlns:a16="http://schemas.microsoft.com/office/drawing/2014/main" id="{673DA78F-E67A-4FA0-8580-B0A112542797}"/>
               </a:ext>
             </a:extLst>
           </p:cNvPr>
@@ -4947,7 +4988,7 @@
                 <a:ea typeface="Manrope"/>
                 <a:cs typeface="Manrope"/>
               </a:rPr>
-              <a:t>ORIGINAL / URI INTERPRETATION</a:t>
+              <a:t>LITERAL FILENAME</a:t>
             </a:r>
             <a:endParaRPr sz="1200" b="1">
               <a:solidFill>
@@ -4965,7 +5006,7 @@
           <p:cNvPr id="48" name="Google Shape;48;p9">
             <a:extLst xmlns:a="http://schemas.openxmlformats.org/drawingml/2006/main">
               <a:ext uri="{FF2B5EF4-FFF2-40B4-BE49-F238E27FC236}">
-                <a16:creationId xmlns:a16="http://schemas.microsoft.com/office/drawing/2014/main" id="{25F3B97E-68DF-48BC-B702-82B8D7B6A17F}"/>
+                <a16:creationId xmlns:a16="http://schemas.microsoft.com/office/drawing/2014/main" id="{0582C36B-24EA-4464-99D1-10889F193841}"/>
               </a:ext>
             </a:extLst>
           </p:cNvPr>
@@ -5011,7 +5052,7 @@
                 <a:ea typeface="Manrope"/>
                 <a:cs typeface="Manrope"/>
               </a:rPr>
-              <a:t>FIX / FILENAME INTERPRETATION</a:t>
+              <a:t>URL REFERENCE</a:t>
             </a:r>
             <a:endParaRPr sz="1200" b="1">
               <a:solidFill>
@@ -5029,7 +5070,7 @@
           <p:cNvPr id="49" name="Google Shape;49;p9">
             <a:extLst xmlns:a="http://schemas.openxmlformats.org/drawingml/2006/main">
               <a:ext uri="{FF2B5EF4-FFF2-40B4-BE49-F238E27FC236}">
-                <a16:creationId xmlns:a16="http://schemas.microsoft.com/office/drawing/2014/main" id="{30244DE0-74F1-45CA-B3A6-63EF5950BD94}"/>
+                <a16:creationId xmlns:a16="http://schemas.microsoft.com/office/drawing/2014/main" id="{BB19D36D-E11D-46EE-A5D5-FD8FC3CC7432}"/>
               </a:ext>
             </a:extLst>
           </p:cNvPr>
@@ -5075,10 +5116,10 @@
                 <a:ea typeface="Roboto Mono"/>
                 <a:cs typeface="Roboto Mono"/>
               </a:rPr>
-              <a:t>Lorem-Ipsum</a:t>
+              <a:t>filename.txt</a:t>
             </a:r>
             <a:r>
-              <a:rPr sz="4800" b="1">
+              <a:rPr sz="4800">
                 <a:solidFill>
                   <a:srgbClr val="D99575"/>
                 </a:solidFill>
@@ -5097,7 +5138,7 @@
                 <a:ea typeface="Roboto Mono"/>
                 <a:cs typeface="Roboto Mono"/>
               </a:rPr>
-              <a:t>123.csv</a:t>
+              <a:t>file2.csv</a:t>
             </a:r>
             <a:endParaRPr sz="4800">
               <a:solidFill>
@@ -5115,7 +5156,7 @@
           <p:cNvPr id="50" name="Google Shape;50;p9">
             <a:extLst xmlns:a="http://schemas.openxmlformats.org/drawingml/2006/main">
               <a:ext uri="{FF2B5EF4-FFF2-40B4-BE49-F238E27FC236}">
-                <a16:creationId xmlns:a16="http://schemas.microsoft.com/office/drawing/2014/main" id="{69C61208-1BBB-4797-A336-F20249086177}"/>
+                <a16:creationId xmlns:a16="http://schemas.microsoft.com/office/drawing/2014/main" id="{C7E6C191-CF51-44BE-B418-AEAF4A48EA63}"/>
               </a:ext>
             </a:extLst>
           </p:cNvPr>
@@ -5161,7 +5202,7 @@
                 <a:ea typeface="Roboto Mono"/>
                 <a:cs typeface="Roboto Mono"/>
               </a:rPr>
-              <a:t>path:     Lorem-Ipsum</a:t>
+              <a:t>filename.txt#file2.csv</a:t>
             </a:r>
             <a:endParaRPr sz="1900">
               <a:solidFill>
@@ -5191,7 +5232,7 @@
                 <a:ea typeface="Roboto Mono"/>
                 <a:cs typeface="Roboto Mono"/>
               </a:rPr>
-              <a:t>fragment: 123.csv</a:t>
+              <a:t># belongs to the name</a:t>
             </a:r>
             <a:endParaRPr sz="1900">
               <a:solidFill>
@@ -5209,7 +5250,7 @@
           <p:cNvPr id="51" name="Google Shape;51;p9">
             <a:extLst xmlns:a="http://schemas.openxmlformats.org/drawingml/2006/main">
               <a:ext uri="{FF2B5EF4-FFF2-40B4-BE49-F238E27FC236}">
-                <a16:creationId xmlns:a16="http://schemas.microsoft.com/office/drawing/2014/main" id="{2C8E7ABC-E18C-4BEF-8234-EE6B993AF7D5}"/>
+                <a16:creationId xmlns:a16="http://schemas.microsoft.com/office/drawing/2014/main" id="{37CCD4EE-621A-4267-B7CB-11929F01C5BC}"/>
               </a:ext>
             </a:extLst>
           </p:cNvPr>
@@ -5232,10 +5273,111 @@
           </a:ln>
         </p:spPr>
         <p:txBody>
-          <a:bodyPr xmlns:a="http://schemas.openxmlformats.org/drawingml/2006/main" spcFirstLastPara="1" wrap="square" lIns="0" tIns="0" rIns="0" bIns="0" anchor="t">
+          <a:bodyPr xmlns:a="http://schemas.openxmlformats.org/drawingml/2006/main" spcFirstLastPara="1" wrap="none" lIns="0" tIns="0" rIns="0" bIns="0" anchor="t">
             <a:noAutofit/>
           </a:bodyPr>
-          <a:lstStyle xmlns:a="http://schemas.openxmlformats.org/drawingml/2006/main"/>
+          <a:lstStyle xmlns:a="http://schemas.openxmlformats.org/drawingml/2006/main">
+            <a:defPPr>
+              <a:defRPr sz="1900">
+                <a:solidFill>
+                  <a:srgbClr val="203B34"/>
+                </a:solidFill>
+                <a:latin typeface="Roboto Mono"/>
+                <a:ea typeface="Roboto Mono"/>
+                <a:cs typeface="Roboto Mono"/>
+              </a:defRPr>
+            </a:defPPr>
+            <a:lvl1pPr>
+              <a:defRPr sz="1900">
+                <a:solidFill>
+                  <a:srgbClr val="203B34"/>
+                </a:solidFill>
+                <a:latin typeface="Roboto Mono"/>
+                <a:ea typeface="Roboto Mono"/>
+                <a:cs typeface="Roboto Mono"/>
+              </a:defRPr>
+            </a:lvl1pPr>
+            <a:lvl2pPr>
+              <a:defRPr sz="1900">
+                <a:solidFill>
+                  <a:srgbClr val="203B34"/>
+                </a:solidFill>
+                <a:latin typeface="Roboto Mono"/>
+                <a:ea typeface="Roboto Mono"/>
+                <a:cs typeface="Roboto Mono"/>
+              </a:defRPr>
+            </a:lvl2pPr>
+            <a:lvl3pPr>
+              <a:defRPr sz="1900">
+                <a:solidFill>
+                  <a:srgbClr val="203B34"/>
+                </a:solidFill>
+                <a:latin typeface="Roboto Mono"/>
+                <a:ea typeface="Roboto Mono"/>
+                <a:cs typeface="Roboto Mono"/>
+              </a:defRPr>
+            </a:lvl3pPr>
+            <a:lvl4pPr>
+              <a:defRPr sz="1900">
+                <a:solidFill>
+                  <a:srgbClr val="203B34"/>
+                </a:solidFill>
+                <a:latin typeface="Roboto Mono"/>
+                <a:ea typeface="Roboto Mono"/>
+                <a:cs typeface="Roboto Mono"/>
+              </a:defRPr>
+            </a:lvl4pPr>
+            <a:lvl5pPr>
+              <a:defRPr sz="1900">
+                <a:solidFill>
+                  <a:srgbClr val="203B34"/>
+                </a:solidFill>
+                <a:latin typeface="Roboto Mono"/>
+                <a:ea typeface="Roboto Mono"/>
+                <a:cs typeface="Roboto Mono"/>
+              </a:defRPr>
+            </a:lvl5pPr>
+            <a:lvl6pPr>
+              <a:defRPr sz="1900">
+                <a:solidFill>
+                  <a:srgbClr val="203B34"/>
+                </a:solidFill>
+                <a:latin typeface="Roboto Mono"/>
+                <a:ea typeface="Roboto Mono"/>
+                <a:cs typeface="Roboto Mono"/>
+              </a:defRPr>
+            </a:lvl6pPr>
+            <a:lvl7pPr>
+              <a:defRPr sz="1900">
+                <a:solidFill>
+                  <a:srgbClr val="203B34"/>
+                </a:solidFill>
+                <a:latin typeface="Roboto Mono"/>
+                <a:ea typeface="Roboto Mono"/>
+                <a:cs typeface="Roboto Mono"/>
+              </a:defRPr>
+            </a:lvl7pPr>
+            <a:lvl8pPr>
+              <a:defRPr sz="1900">
+                <a:solidFill>
+                  <a:srgbClr val="203B34"/>
+                </a:solidFill>
+                <a:latin typeface="Roboto Mono"/>
+                <a:ea typeface="Roboto Mono"/>
+                <a:cs typeface="Roboto Mono"/>
+              </a:defRPr>
+            </a:lvl8pPr>
+            <a:lvl9pPr>
+              <a:defRPr sz="1900">
+                <a:solidFill>
+                  <a:srgbClr val="203B34"/>
+                </a:solidFill>
+                <a:latin typeface="Roboto Mono"/>
+                <a:ea typeface="Roboto Mono"/>
+                <a:cs typeface="Roboto Mono"/>
+              </a:defRPr>
+            </a:lvl9pPr>
+          </a:lstStyle>
           <a:p xmlns:a="http://schemas.openxmlformats.org/drawingml/2006/main">
             <a:pPr marL="0" marR="0" lvl="0" indent="0" algn="l">
               <a:spcBef>
@@ -5245,9 +5387,17 @@
                 <a:spcPts val="0"/>
               </a:spcAft>
               <a:buNone/>
+              <a:defRPr sz="1900">
+                <a:solidFill>
+                  <a:srgbClr val="203B34"/>
+                </a:solidFill>
+                <a:latin typeface="Roboto Mono"/>
+                <a:ea typeface="Roboto Mono"/>
+                <a:cs typeface="Roboto Mono"/>
+              </a:defRPr>
             </a:pPr>
             <a:r>
-              <a:rPr sz="2200">
+              <a:rPr sz="1900">
                 <a:solidFill>
                   <a:srgbClr val="203B34"/>
                 </a:solidFill>
@@ -5255,7 +5405,45 @@
                 <a:ea typeface="Roboto Mono"/>
                 <a:cs typeface="Roboto Mono"/>
               </a:rPr>
-              <a:t>Lorem-Ipsum#123.csv</a:t>
+              <a:t>path: filename.txt</a:t>
+            </a:r>
+            <a:endParaRPr sz="2200">
+              <a:solidFill>
+                <a:srgbClr val="203B34"/>
+              </a:solidFill>
+              <a:latin typeface="Roboto Mono"/>
+              <a:ea typeface="Roboto Mono"/>
+              <a:cs typeface="Roboto Mono"/>
+            </a:endParaRPr>
+          </a:p>
+          <a:p xmlns:a="http://schemas.openxmlformats.org/drawingml/2006/main">
+            <a:pPr marL="0" marR="0" lvl="0" indent="0" algn="l">
+              <a:spcBef>
+                <a:spcPts val="0"/>
+              </a:spcBef>
+              <a:spcAft>
+                <a:spcPts val="0"/>
+              </a:spcAft>
+              <a:buNone/>
+              <a:defRPr sz="1900">
+                <a:solidFill>
+                  <a:srgbClr val="203B34"/>
+                </a:solidFill>
+                <a:latin typeface="Roboto Mono"/>
+                <a:ea typeface="Roboto Mono"/>
+                <a:cs typeface="Roboto Mono"/>
+              </a:defRPr>
+            </a:pPr>
+            <a:r>
+              <a:rPr sz="1900">
+                <a:solidFill>
+                  <a:srgbClr val="203B34"/>
+                </a:solidFill>
+                <a:latin typeface="Roboto Mono"/>
+                <a:ea typeface="Roboto Mono"/>
+                <a:cs typeface="Roboto Mono"/>
+              </a:rPr>
+              <a:t>fragment: file2.csv</a:t>
             </a:r>
             <a:endParaRPr sz="2200">
               <a:solidFill>
@@ -5273,7 +5461,7 @@
           <p:cNvPr id="52" name="Google Shape;52;p9">
             <a:extLst xmlns:a="http://schemas.openxmlformats.org/drawingml/2006/main">
               <a:ext uri="{FF2B5EF4-FFF2-40B4-BE49-F238E27FC236}">
-                <a16:creationId xmlns:a16="http://schemas.microsoft.com/office/drawing/2014/main" id="{F74ECEAF-C9A7-4B8C-80B6-A597893DE40B}"/>
+                <a16:creationId xmlns:a16="http://schemas.microsoft.com/office/drawing/2014/main" id="{57C00220-F9E9-4F9A-98D0-B6D74940FE0E}"/>
               </a:ext>
             </a:extLst>
           </p:cNvPr>
@@ -5319,7 +5507,7 @@
                 <a:ea typeface="Roboto Mono"/>
                 <a:cs typeface="Roboto Mono"/>
               </a:rPr>
-              <a:t>text/csv</a:t>
+              <a:t>TXT extension</a:t>
             </a:r>
             <a:endParaRPr sz="2600" b="1">
               <a:solidFill>
@@ -5337,7 +5525,7 @@
           <p:cNvPr id="53" name="Google Shape;53;p9">
             <a:extLst xmlns:a="http://schemas.openxmlformats.org/drawingml/2006/main">
               <a:ext uri="{FF2B5EF4-FFF2-40B4-BE49-F238E27FC236}">
-                <a16:creationId xmlns:a16="http://schemas.microsoft.com/office/drawing/2014/main" id="{78BEBD94-1937-4402-8CB9-4F8FD4256179}"/>
+                <a16:creationId xmlns:a16="http://schemas.microsoft.com/office/drawing/2014/main" id="{4F7EE224-A1CC-47FD-92C2-FB6E8754FEEE}"/>
               </a:ext>
             </a:extLst>
           </p:cNvPr>
@@ -5383,7 +5571,7 @@
                 <a:ea typeface="Roboto Mono"/>
                 <a:cs typeface="Roboto Mono"/>
               </a:rPr>
-              <a:t>text/plain</a:t>
+              <a:t>CSV extension</a:t>
             </a:r>
             <a:endParaRPr sz="2600" b="1">
               <a:solidFill>
@@ -5401,7 +5589,7 @@
           <p:cNvPr id="54" name="Google Shape;54;p9">
             <a:extLst xmlns:a="http://schemas.openxmlformats.org/drawingml/2006/main">
               <a:ext uri="{FF2B5EF4-FFF2-40B4-BE49-F238E27FC236}">
-                <a16:creationId xmlns:a16="http://schemas.microsoft.com/office/drawing/2014/main" id="{999F124F-30B3-4A8F-B5BA-9D81C83092BC}"/>
+                <a16:creationId xmlns:a16="http://schemas.microsoft.com/office/drawing/2014/main" id="{CEF19A96-4FA8-438B-AC56-C8E3718EF37C}"/>
               </a:ext>
             </a:extLst>
           </p:cNvPr>
@@ -5427,7 +5615,38 @@
           <a:bodyPr xmlns:a="http://schemas.openxmlformats.org/drawingml/2006/main" spcFirstLastPara="1" wrap="square" lIns="0" tIns="0" rIns="0" bIns="0" anchor="t">
             <a:noAutofit/>
           </a:bodyPr>
-          <a:lstStyle xmlns:a="http://schemas.openxmlformats.org/drawingml/2006/main"/>
+          <a:lstStyle xmlns:a="http://schemas.openxmlformats.org/drawingml/2006/main">
+            <a:defPPr>
+              <a:defRPr b="1"/>
+            </a:defPPr>
+            <a:lvl1pPr>
+              <a:defRPr b="1"/>
+            </a:lvl1pPr>
+            <a:lvl2pPr>
+              <a:defRPr b="1"/>
+            </a:lvl2pPr>
+            <a:lvl3pPr>
+              <a:defRPr b="1"/>
+            </a:lvl3pPr>
+            <a:lvl4pPr>
+              <a:defRPr b="1"/>
+            </a:lvl4pPr>
+            <a:lvl5pPr>
+              <a:defRPr b="1"/>
+            </a:lvl5pPr>
+            <a:lvl6pPr>
+              <a:defRPr b="1"/>
+            </a:lvl6pPr>
+            <a:lvl7pPr>
+              <a:defRPr b="1"/>
+            </a:lvl7pPr>
+            <a:lvl8pPr>
+              <a:defRPr b="1"/>
+            </a:lvl8pPr>
+            <a:lvl9pPr>
+              <a:defRPr b="1"/>
+            </a:lvl9pPr>
+          </a:lstStyle>
           <a:p xmlns:a="http://schemas.openxmlformats.org/drawingml/2006/main">
             <a:pPr marL="0" marR="0" lvl="0" indent="0" algn="l">
               <a:spcBef>
@@ -5437,9 +5656,10 @@
                 <a:spcPts val="0"/>
               </a:spcAft>
               <a:buNone/>
+              <a:defRPr b="1"/>
             </a:pPr>
             <a:r>
-              <a:rPr sz="1250">
+              <a:rPr sz="1250" b="1">
                 <a:solidFill>
                   <a:srgbClr val="203B34"/>
                 </a:solidFill>
@@ -5447,7 +5667,7 @@
                 <a:ea typeface="Manrope"/>
                 <a:cs typeface="Manrope"/>
               </a:rPr>
-              <a:t>Same CSV content. The missing extension changed the result.</a:t>
+              <a:t>We needed a policy for ambiguous input, then tests for both interpretations.</a:t>
             </a:r>
             <a:endParaRPr sz="1250">
               <a:solidFill>
@@ -5460,10 +5680,166 @@
           </a:p>
         </p:txBody>
       </p:sp>
+      <p:sp>
+        <p:nvSpPr>
+          <p:cNvPr id="2" name="final-handoff-slide-number">
+            <a:extLst xmlns:a="http://schemas.openxmlformats.org/drawingml/2006/main">
+              <a:ext uri="{FF2B5EF4-FFF2-40B4-BE49-F238E27FC236}">
+                <a16:creationId xmlns:a16="http://schemas.microsoft.com/office/drawing/2014/main" id="{5289803D-4E40-4670-BBC8-CF77B95C40DE}"/>
+              </a:ext>
+            </a:extLst>
+          </p:cNvPr>
+          <p:cNvSpPr>
+            <a:spLocks xmlns:a="http://schemas.openxmlformats.org/drawingml/2006/main" noGrp="1"/>
+          </p:cNvSpPr>
+          <p:nvPr/>
+        </p:nvSpPr>
+        <p:spPr>
+          <a:xfrm xmlns:a="http://schemas.openxmlformats.org/drawingml/2006/main">
+            <a:off x="10871168" y="330232"/>
+            <a:ext cx="711327" cy="279273"/>
+          </a:xfrm>
+          <a:prstGeom xmlns:a="http://schemas.openxmlformats.org/drawingml/2006/main" prst="rect">
+            <a:avLst/>
+          </a:prstGeom>
+          <a:noFill xmlns:a="http://schemas.openxmlformats.org/drawingml/2006/main"/>
+          <a:ln xmlns:a="http://schemas.openxmlformats.org/drawingml/2006/main" w="0">
+            <a:noFill/>
+          </a:ln>
+        </p:spPr>
+        <p:txBody>
+          <a:bodyPr xmlns:a="http://schemas.openxmlformats.org/drawingml/2006/main"/>
+          <a:lstStyle xmlns:a="http://schemas.openxmlformats.org/drawingml/2006/main">
+            <a:defPPr algn="r">
+              <a:defRPr sz="1100">
+                <a:solidFill>
+                  <a:srgbClr val="B8C7AB"/>
+                </a:solidFill>
+                <a:latin typeface="Roboto Mono"/>
+                <a:ea typeface="Roboto Mono"/>
+                <a:cs typeface="Roboto Mono"/>
+              </a:defRPr>
+            </a:defPPr>
+            <a:lvl1pPr algn="r">
+              <a:defRPr sz="1100">
+                <a:solidFill>
+                  <a:srgbClr val="B8C7AB"/>
+                </a:solidFill>
+                <a:latin typeface="Roboto Mono"/>
+                <a:ea typeface="Roboto Mono"/>
+                <a:cs typeface="Roboto Mono"/>
+              </a:defRPr>
+            </a:lvl1pPr>
+            <a:lvl2pPr algn="r">
+              <a:defRPr sz="1100">
+                <a:solidFill>
+                  <a:srgbClr val="B8C7AB"/>
+                </a:solidFill>
+                <a:latin typeface="Roboto Mono"/>
+                <a:ea typeface="Roboto Mono"/>
+                <a:cs typeface="Roboto Mono"/>
+              </a:defRPr>
+            </a:lvl2pPr>
+            <a:lvl3pPr algn="r">
+              <a:defRPr sz="1100">
+                <a:solidFill>
+                  <a:srgbClr val="B8C7AB"/>
+                </a:solidFill>
+                <a:latin typeface="Roboto Mono"/>
+                <a:ea typeface="Roboto Mono"/>
+                <a:cs typeface="Roboto Mono"/>
+              </a:defRPr>
+            </a:lvl3pPr>
+            <a:lvl4pPr algn="r">
+              <a:defRPr sz="1100">
+                <a:solidFill>
+                  <a:srgbClr val="B8C7AB"/>
+                </a:solidFill>
+                <a:latin typeface="Roboto Mono"/>
+                <a:ea typeface="Roboto Mono"/>
+                <a:cs typeface="Roboto Mono"/>
+              </a:defRPr>
+            </a:lvl4pPr>
+            <a:lvl5pPr algn="r">
+              <a:defRPr sz="1100">
+                <a:solidFill>
+                  <a:srgbClr val="B8C7AB"/>
+                </a:solidFill>
+                <a:latin typeface="Roboto Mono"/>
+                <a:ea typeface="Roboto Mono"/>
+                <a:cs typeface="Roboto Mono"/>
+              </a:defRPr>
+            </a:lvl5pPr>
+            <a:lvl6pPr algn="r">
+              <a:defRPr sz="1100">
+                <a:solidFill>
+                  <a:srgbClr val="B8C7AB"/>
+                </a:solidFill>
+                <a:latin typeface="Roboto Mono"/>
+                <a:ea typeface="Roboto Mono"/>
+                <a:cs typeface="Roboto Mono"/>
+              </a:defRPr>
+            </a:lvl6pPr>
+            <a:lvl7pPr algn="r">
+              <a:defRPr sz="1100">
+                <a:solidFill>
+                  <a:srgbClr val="B8C7AB"/>
+                </a:solidFill>
+                <a:latin typeface="Roboto Mono"/>
+                <a:ea typeface="Roboto Mono"/>
+                <a:cs typeface="Roboto Mono"/>
+              </a:defRPr>
+            </a:lvl7pPr>
+            <a:lvl8pPr algn="r">
+              <a:defRPr sz="1100">
+                <a:solidFill>
+                  <a:srgbClr val="B8C7AB"/>
+                </a:solidFill>
+                <a:latin typeface="Roboto Mono"/>
+                <a:ea typeface="Roboto Mono"/>
+                <a:cs typeface="Roboto Mono"/>
+              </a:defRPr>
+            </a:lvl8pPr>
+            <a:lvl9pPr algn="r">
+              <a:defRPr sz="1100">
+                <a:solidFill>
+                  <a:srgbClr val="B8C7AB"/>
+                </a:solidFill>
+                <a:latin typeface="Roboto Mono"/>
+                <a:ea typeface="Roboto Mono"/>
+                <a:cs typeface="Roboto Mono"/>
+              </a:defRPr>
+            </a:lvl9pPr>
+          </a:lstStyle>
+          <a:p xmlns:a="http://schemas.openxmlformats.org/drawingml/2006/main">
+            <a:pPr algn="r">
+              <a:defRPr sz="1100">
+                <a:solidFill>
+                  <a:srgbClr val="B8C7AB"/>
+                </a:solidFill>
+                <a:latin typeface="Roboto Mono"/>
+                <a:ea typeface="Roboto Mono"/>
+                <a:cs typeface="Roboto Mono"/>
+              </a:defRPr>
+            </a:pPr>
+            <a:r>
+              <a:rPr sz="1100">
+                <a:solidFill>
+                  <a:srgbClr val="B8C7AB"/>
+                </a:solidFill>
+                <a:latin typeface="Roboto Mono"/>
+                <a:ea typeface="Roboto Mono"/>
+                <a:cs typeface="Roboto Mono"/>
+              </a:rPr>
+              <a:t>03</a:t>
+            </a:r>
+          </a:p>
+        </p:txBody>
+      </p:sp>
     </p:spTree>
     <p:extLst>
       <p:ext uri="{BB962C8B-B14F-4D97-AF65-F5344CB8AC3E}">
-        <p14:creationId xmlns:p14="http://schemas.microsoft.com/office/powerpoint/2010/main" val="978995728"/>
+        <p14:creationId xmlns:p14="http://schemas.microsoft.com/office/powerpoint/2010/main" val="443491825"/>
       </p:ext>
     </p:extLst>
   </p:cSld>

</xml_diff>